<commit_message>
Practice rooms: Development D2 (L01–L12); tidy D1-L05 builder
Co-Authored-By: Claude Opus 5.5 <noreply@anthropic.com>
Claude-Session: https://claude.ai/code/session_01QWUKnGV7MRCnE8883pixoX
</commit_message>
<xml_diff>
--- a/Development_D1/Guided_Practice/D1-L05_Practice_Room_After_School_and_Evening.pptx
+++ b/Development_D1/Guided_Practice/D1-L05_Practice_Room_After_School_and_Evening.pptx
@@ -8501,7 +8501,7 @@
                 <a:latin typeface="Calibri" pitchFamily="34" charset="0"/>
                 <a:cs typeface="Amiri" pitchFamily="2" charset="-78"/>
               </a:rPr>
-              <a:t>I tidy my room and prepare it.</a:t>
+              <a:t>I tidy my room and clean it every evening.</a:t>
             </a:r>
             <a:endParaRPr lang="en-US" sz="1400" dirty="0"/>
           </a:p>
@@ -9009,20 +9009,21 @@
           <a:bodyPr wrap="square" lIns="0" tIns="0" rIns="0" bIns="0" rtlCol="0" anchor="ctr"/>
           <a:lstStyle/>
           <a:p>
-            <a:pPr algn="l" indent="0" marL="0">
-              <a:buNone/>
-            </a:pPr>
-            <a:r>
-              <a:rPr lang="en-US" sz="1800" dirty="0">
+            <a:pPr rtl="1" algn="r" indent="0" marL="0">
+              <a:buNone/>
+            </a:pPr>
+            <a:r>
+              <a:rPr lang="ar-SA" altLang="en-US" sz="1800" dirty="0">
                 <a:solidFill>
                   <a:srgbClr val="1F2A37"/>
                 </a:solidFill>
-                <a:latin typeface="Calibri" pitchFamily="34" charset="0"/>
-                <a:cs typeface="Amiri" pitchFamily="2" charset="-78"/>
-              </a:rPr>
-              <a:t>.</a:t>
-            </a:r>
-            <a:endParaRPr lang="en-US" sz="1800" dirty="0"/>
+                <a:latin typeface="Amiri" pitchFamily="2" charset="-78"/>
+                <a:ea typeface="Amiri" pitchFamily="2" charset="-78"/>
+                <a:cs typeface="Amiri" pitchFamily="2" charset="-78"/>
+              </a:rPr>
+              <a:t>كُلَّ مَسَاءٍ.</a:t>
+            </a:r>
+            <a:endParaRPr lang="ar-SA" sz="1800" dirty="0"/>
           </a:p>
         </p:txBody>
       </p:sp>
@@ -9124,7 +9125,7 @@
                 <a:ea typeface="Amiri" pitchFamily="2" charset="-78"/>
                 <a:cs typeface="Amiri" pitchFamily="2" charset="-78"/>
               </a:rPr>
-              <a:t>أَمْسِ.</a:t>
+              <a:t>كُلُّ مَسَاءٌ.</a:t>
             </a:r>
             <a:endParaRPr lang="ar-SA" sz="1800" dirty="0"/>
           </a:p>
@@ -10829,7 +10830,7 @@
                 <a:latin typeface="Calibri" pitchFamily="34" charset="0"/>
                 <a:cs typeface="Amiri" pitchFamily="2" charset="-78"/>
               </a:rPr>
-              <a:t>I tidy my room and prepare it.</a:t>
+              <a:t>I tidy my room and clean it every evening.</a:t>
             </a:r>
             <a:endParaRPr lang="en-US" sz="1300" dirty="0"/>
           </a:p>
@@ -10946,6 +10947,33 @@
                 <a:latin typeface="Calibri" pitchFamily="34" charset="0"/>
                 <a:cs typeface="Amiri" pitchFamily="2" charset="-78"/>
               </a:rPr>
+              <a:t>; every evening = </a:t>
+            </a:r>
+            <a:pPr algn="l" indent="0" marL="0">
+              <a:buNone/>
+            </a:pPr>
+            <a:r>
+              <a:rPr lang="ar-SA" altLang="en-US" sz="1350" dirty="0">
+                <a:solidFill>
+                  <a:srgbClr val="5A6472"/>
+                </a:solidFill>
+                <a:latin typeface="Amiri" pitchFamily="2" charset="-78"/>
+                <a:ea typeface="Amiri" pitchFamily="2" charset="-78"/>
+                <a:cs typeface="Amiri" pitchFamily="2" charset="-78"/>
+              </a:rPr>
+              <a:t>كُلَّ مَسَاءٍ</a:t>
+            </a:r>
+            <a:pPr algn="l" indent="0" marL="0">
+              <a:buNone/>
+            </a:pPr>
+            <a:r>
+              <a:rPr lang="en-US" sz="1050" i="1" dirty="0">
+                <a:solidFill>
+                  <a:srgbClr val="5A6472"/>
+                </a:solidFill>
+                <a:latin typeface="Calibri" pitchFamily="34" charset="0"/>
+                <a:cs typeface="Amiri" pitchFamily="2" charset="-78"/>
+              </a:rPr>
               <a:t>.</a:t>
             </a:r>
             <a:endParaRPr lang="en-US" sz="1050" dirty="0"/>
@@ -10985,7 +11013,7 @@
                 <a:ea typeface="Amiri" pitchFamily="2" charset="-78"/>
                 <a:cs typeface="Amiri" pitchFamily="2" charset="-78"/>
               </a:rPr>
-              <a:t>أُرَتِّبُ غُرْفَتِي وَأُنَظِّفُهَا .</a:t>
+              <a:t>أُرَتِّبُ غُرْفَتِي وَأُنَظِّفُهَا كُلَّ مَسَاءٍ.</a:t>
             </a:r>
             <a:endParaRPr lang="ar-SA" sz="2800" dirty="0"/>
           </a:p>

</xml_diff>